<commit_message>
ALAGA: wheeled home companion for older adults home alone
The robot now drives on two geared motors along a floor-tape route between
home stations, reminds about medicine, water, and check-ins, checks vital
signs, keeps company with music and prayers, and reports to the family
through Telegram. A new ESP32-C3 pendant detects falls and sends SOS by
ESP-NOW. Paper, PR2 deck, build guide, and programs updated to match.

Co-Authored-By: Claude Opus 5.5 <noreply@anthropic.com>
Claude-Session: https://claude.ai/code/session_01MfReZH7HCVc5jwegZ7NE6b
</commit_message>
<xml_diff>
--- a/research/RIM3_ALAGA/RIM3_ALAGA_PR2_Presentation.pptx
+++ b/research/RIM3_ALAGA/RIM3_ALAGA_PR2_Presentation.pptx
@@ -530,7 +530,7 @@
           <a:p/>
           <a:p>
             <a:r>
-              <a:t>Good morning to the panel. We are [names], with our adviser, [adviser]. Our study is titled ALAGA, a low-cost soft inflatable healthcare companion robot.</a:t>
+              <a:t>Good morning to the panel. We are [names], with our adviser, [adviser]. Our study is titled ALAGA, a low-cost wheeled soft companion robot for older adults who stay home alone.</a:t>
             </a:r>
           </a:p>
         </p:txBody>
@@ -752,7 +752,7 @@
           <a:p/>
           <a:p>
             <a:r>
-              <a:t>Mayon was raised to Alert Level 3 in January 2026, and in May ash fell on 87 villages. More than 300 families moved to evacuation centers. There, a few health workers must check every evacuee for fever, low oxygen, and pain. Healthcare robots exist, but they are rigid and costly. Our purpose: to find out whether a low-cost soft robot, inspired by the healthcare companion in Big Hero 6, can screen evacuees accurately.</a:t>
+              <a:t>Many older adults stay home alone while their children work. A missed medicine, a fever, or a fall can go unnoticed until evening. Adults over 60 suffer the most fatal falls, and about half of patients on long-term medicines miss doses. Paid caregivers and companion robots cost too much. Our purpose: to find out whether a low-cost wheeled soft robot, inspired by Big Hero 6, can watch over an older adult and keep the family informed.</a:t>
             </a:r>
           </a:p>
         </p:txBody>
@@ -828,7 +828,7 @@
           <a:p/>
           <a:p>
             <a:r>
-              <a:t>From the literature: soft and inflatable robots are safer to touch; older adults accept robots that look friendly and are easy to use; pulse oximetry and infrared thermometry can screen vital signs; and Bland and Altman's limits of agreement test whether a new instrument can be trusted.</a:t>
+              <a:t>From the literature: soft robots are safer to bump into; companion robots improve the mood of older adults; falls can be detected with an accelerometer; and new health sensors must be checked with Bland–Altman agreement.</a:t>
             </a:r>
           </a:p>
         </p:txBody>
@@ -904,7 +904,7 @@
           <a:p/>
           <a:p>
             <a:r>
-              <a:t>Related studies built an inflatable arm for safe contact, reviewed acceptance of care robots, and gave us the agreement method. None joins a soft body, vital-sign screening, and pain triage for evacuation centers.</a:t>
+              <a:t>Related studies placed a seal robot with older adults, detected falls with accelerometer thresholds, and gave us the agreement method. None joins all of these in one low-cost mobile robot.</a:t>
             </a:r>
           </a:p>
         </p:txBody>
@@ -980,7 +980,7 @@
           <a:p/>
           <a:p>
             <a:r>
-              <a:t>Our framework answers four gaps. Few health workers: a socially assistive robot does the routine checks. Robots can scare people: an air-filled body and a plain two-dot face. Cheap sensors vary: we calibrate and test agreement. Who needs help first: a state machine gives GREEN, YELLOW, or RED.</a:t>
+              <a:t>Our framework answers four gaps. Alone at home: a companion robot that reports to the family. Falls unnoticed: a pendant that alerts in seconds. Robots can scare: a soft, slow body with a plain face. Cheap sensors vary: we calibrate and test agreement.</a:t>
             </a:r>
           </a:p>
         </p:txBody>
@@ -1056,7 +1056,7 @@
           <a:p/>
           <a:p>
             <a:r>
-              <a:t>Our paradigm follows input, process, output. Inputs are the body, sensors, reference instruments, and volunteers. The process is building, calibration, trials, and analysis. Outputs answer each objective, and results feed back to tune the offsets and limits.</a:t>
+              <a:t>Inputs are the soft body, the wheeled base, the sensors, the pendant, Wi-Fi, and reference instruments. We build, program, tape the route, calibrate, and test. Outputs answer each objective, and results tune the calibration, fall thresholds, and speed.</a:t>
             </a:r>
           </a:p>
         </p:txBody>
@@ -1132,7 +1132,7 @@
           <a:p/>
           <a:p>
             <a:r>
-              <a:t>Evacuees get a friendly, quick screening. Health workers spend more time on flagged evacuees. LGUs get an affordable aid for every center, schools a clinic helper, and future researchers a tested open design. The study supports SDGs 3, 9, and 11.5.</a:t>
+              <a:t>Older adults get reminders, checks, company, and help. Working families and OFWs get reports and alerts on their phones. Health workers get a low-cost aid. The study supports SDGs 3, 9, and 10.</a:t>
             </a:r>
           </a:p>
         </p:txBody>
@@ -1208,7 +1208,7 @@
           <a:p/>
           <a:p>
             <a:r>
-              <a:t>Our general objective: to design, build, and evaluate ALAGA. Specifically: agreement with reference instruments, accuracy of flags, screening time, usability and approachability of the soft body versus a rigid shell, and cost.</a:t>
+              <a:t>Our general objective: to design, build, and evaluate ALAGA. Specifically: navigation, health-check agreement, fall detection and alert time, reminders and messages, usability and approachability, and cost.</a:t>
             </a:r>
           </a:p>
         </p:txBody>
@@ -1284,7 +1284,7 @@
           <a:p/>
           <a:p>
             <a:r>
-              <a:t>H₀1: there is no significant difference between ALAGA's readings and the reference readings; we use a paired t-test and Bland–Altman analysis. H₀2: there is no significant difference in approachability between the soft body and a rigid shell; we use the Wilcoxon signed-rank test. We reject when p is below 0.05.</a:t>
+              <a:t>H₀1: no difference between ALAGA's readings and the reference; paired t-test. H₀2: the pendant's decision is not associated with the true event; chi-square. H₀3: no difference in approachability between soft and rigid; Wilcoxon. We reject when p is below 0.05.</a:t>
             </a:r>
           </a:p>
         </p:txBody>
@@ -1360,7 +1360,7 @@
           <a:p/>
           <a:p>
             <a:r>
-              <a:t>We cover one stationary robot that screens temperature, pulse, oxygen, and pain, tested on healthy volunteers after IRB approval. ALAGA does not walk or diagnose, and fever and low oxygen are simulated by a water bath and logic test cases. Table 4 lists our trials.</a:t>
+              <a:t>We cover one robot on a tape route through a mock home, with reminders, health checks, a fall pendant, and Telegram alerts. ALAGA has no arms, does not diagnose, and does not map rooms. Only the researchers simulate falls, on mats.</a:t>
             </a:r>
           </a:p>
         </p:txBody>
@@ -1436,7 +1436,7 @@
           <a:p/>
           <a:p>
             <a:r>
-              <a:t>This is a quantitative developmental and method-comparison study. We build and calibrate, program the logic, screen volunteers, and analyze. We vary the measurement method, target temperature, and body type, and we measure agreement, flag accuracy, time, and ratings.</a:t>
+              <a:t>This is a quantitative developmental study. We build and calibrate, program, run the trials, and analyze. We vary the station, the method, the event, and the body type.</a:t>
             </a:r>
           </a:p>
         </p:txBody>
@@ -1512,7 +1512,7 @@
           <a:p/>
           <a:p>
             <a:r>
-              <a:t>ALAGA's body is white ripstop nylon kept full by a 12-volt fan. The chest panel holds the infrared thermometer, distance sensor, finger cradle, pain dial, and display. An ESP32 runs everything from a 12-volt battery. The parts are estimated at about 4,600 pesos.</a:t>
+              <a:t>ALAGA has a soft nylon body on a 40-centimeter wheeled base. It follows tape with a line sensor and stops for obstacles. The chest holds the health sensors. The pendant detects falls. Parts are estimated at about 6,600 pesos.</a:t>
             </a:r>
           </a:p>
         </p:txBody>
@@ -1588,7 +1588,7 @@
           <a:p/>
           <a:p>
             <a:r>
-              <a:t>The procedure has ten steps: IRB approval and consent; sew the body; wire the sensors; program the state machine; bench-test with a water bath; calibrate on ten volunteers; screen validation volunteers; run logic tests; run the usability test; and analyze.</a:t>
+              <a:t>Ten steps: IRB approval; build the body and base; wire; program; tape the route; calibrate; navigation and health trials; simulated falls; reminders and usability; and analysis.</a:t>
             </a:r>
           </a:p>
         </p:txBody>
@@ -1664,7 +1664,7 @@
           <a:p/>
           <a:p>
             <a:r>
-              <a:t>For each paired reading we take the difference. Bias is the mean difference, and the limits of agreement are bias plus or minus 1.96 standard deviations. Arms is the SpO₂ root-mean-square error, accepted at 4 percent or less. Flags are judged by sensitivity and specificity. We use Excel and JASP at alpha 0.05.</a:t>
+              <a:t>Navigation is judged by success rate. Health checks by bias, limits of agreement, and Arms. The pendant by sensitivity and specificity, and alerts by time to the phone. We use Excel and JASP at alpha 0.05.</a:t>
             </a:r>
           </a:p>
         </p:txBody>
@@ -1740,7 +1740,7 @@
           <a:p/>
           <a:p>
             <a:r>
-              <a:t>Because we work with people, the school IRB approves our plan first, and every volunteer gives consent. Tests are non-invasive, data are coded, and any abnormal reading goes to the nurse. The fan is guarded, the battery is fused, and sensors are wiped with alcohol.</a:t>
+              <a:t>The school IRB approves our plan first, and everyone gives consent. Older adults only do seated checks; only we simulate falls, on mats. The robot is slow and soft, the fan is guarded, and the battery is fused.</a:t>
             </a:r>
           </a:p>
         </p:txBody>
@@ -5021,7 +5021,7 @@
                 <a:cs typeface="Times New Roman"/>
                 <a:sym typeface="Times New Roman"/>
               </a:rPr>
-              <a:t>ALAGA: A Low-Cost Soft Inflatable Healthcare Companion Robot with Non-Contact Temperature, Pulse Oximetry, and Pain-Scale Triage for Evacuation Centers</a:t>
+              <a:t>ALAGA: A Low-Cost Wheeled Soft Inflatable Companion Robot for Older Adults Home Alone, with Medication Reminders, Vital-Sign Checks, and Fall Alerts to the Family</a:t>
             </a:r>
             <a:endParaRPr lang="en-US" sz="5700" dirty="0">
               <a:latin typeface="ITC Avant Garde Gothic"/>
@@ -5525,7 +5525,7 @@
                 </a:solidFill>
                 <a:latin typeface="ITC Avant Garde Gothic"/>
               </a:rPr>
-              <a:t>•  One stationary robot, about 1.1 m tall, fan-inflated</a:t>
+              <a:t>•  One robot, 1.35 m tall, two-wheel drive</a:t>
             </a:r>
           </a:p>
           <a:p>
@@ -5541,7 +5541,7 @@
                 </a:solidFill>
                 <a:latin typeface="ITC Avant Garde Gothic"/>
               </a:rPr>
-              <a:t>•  Forehead temperature, pulse rate, SpO₂, pain 0–10</a:t>
+              <a:t>•  Tape route: dock, chair, bed, kitchen</a:t>
             </a:r>
           </a:p>
           <a:p>
@@ -5557,7 +5557,7 @@
                 </a:solidFill>
                 <a:latin typeface="ITC Avant Garde Gothic"/>
               </a:rPr>
-              <a:t>•  Filipino and English prompts; chest display; log</a:t>
+              <a:t>•  Medicine, water, check-in reminders; health checks</a:t>
             </a:r>
           </a:p>
           <a:p>
@@ -5573,7 +5573,7 @@
                 </a:solidFill>
                 <a:latin typeface="ITC Avant Garde Gothic"/>
               </a:rPr>
-              <a:t>•  Healthy volunteers aged 15+, after IRB approval</a:t>
+              <a:t>•  Fall and SOS pendant; Telegram alerts</a:t>
             </a:r>
           </a:p>
           <a:p>
@@ -5589,7 +5589,7 @@
                 </a:solidFill>
                 <a:latin typeface="ITC Avant Garde Gothic"/>
               </a:rPr>
-              <a:t>•  Water-bath bench test of the IR thermometer</a:t>
+              <a:t>•  Mock home; older adults 60+ after IRB approval</a:t>
             </a:r>
           </a:p>
         </p:txBody>
@@ -5713,7 +5713,7 @@
                 </a:solidFill>
                 <a:latin typeface="ITC Avant Garde Gothic"/>
               </a:rPr>
-              <a:t>•  No walking, arms, or touching</a:t>
+              <a:t>•  No arms; cannot give medicine</a:t>
             </a:r>
           </a:p>
           <a:p>
@@ -5729,7 +5729,7 @@
                 </a:solidFill>
                 <a:latin typeface="ITC Avant Garde Gothic"/>
               </a:rPr>
-              <a:t>•  Screens and refers only; not a medical device</a:t>
+              <a:t>•  Not a medical device; no diagnosis</a:t>
             </a:r>
           </a:p>
           <a:p>
@@ -5745,7 +5745,7 @@
                 </a:solidFill>
                 <a:latin typeface="ITC Avant Garde Gothic"/>
               </a:rPr>
-              <a:t>•  No blood pressure or respiratory rate</a:t>
+              <a:t>•  No mapping, stairs, or high door sills</a:t>
             </a:r>
           </a:p>
           <a:p>
@@ -5761,7 +5761,7 @@
                 </a:solidFill>
                 <a:latin typeface="ITC Avant Garde Gothic"/>
               </a:rPr>
-              <a:t>•  Fever and low SpO₂ simulated, not from patients</a:t>
+              <a:t>•  Falls simulated only by researchers on mats</a:t>
             </a:r>
           </a:p>
           <a:p>
@@ -5777,7 +5777,7 @@
                 </a:solidFill>
                 <a:latin typeface="ITC Avant Garde Gothic"/>
               </a:rPr>
-              <a:t>•  Tested in school, not in a real evacuation center</a:t>
+              <a:t>•  Needs home Wi-Fi; not tested for weeks</a:t>
             </a:r>
           </a:p>
         </p:txBody>
@@ -5948,7 +5948,7 @@
                           </a:solidFill>
                           <a:latin typeface="ITC Avant Garde Gothic"/>
                         </a:rPr>
-                        <a:t>Bench</a:t>
+                        <a:t>Navigation</a:t>
                       </a:r>
                     </a:p>
                   </a:txBody>
@@ -5970,7 +5970,7 @@
                           </a:solidFill>
                           <a:latin typeface="ITC Avant Garde Gothic"/>
                         </a:rPr>
-                        <a:t>IR temperature, 35–40 °C target</a:t>
+                        <a:t>Arrival, time, obstacle stops</a:t>
                       </a:r>
                     </a:p>
                   </a:txBody>
@@ -5992,7 +5992,7 @@
                           </a:solidFill>
                           <a:latin typeface="ITC Avant Garde Gothic"/>
                         </a:rPr>
-                        <a:t>6 × 10</a:t>
+                        <a:t>____ trips; 30 obstacles</a:t>
                       </a:r>
                     </a:p>
                   </a:txBody>
@@ -6014,7 +6014,7 @@
                           </a:solidFill>
                           <a:latin typeface="ITC Avant Garde Gothic"/>
                         </a:rPr>
-                        <a:t>Probe thermometer</a:t>
+                        <a:t>Stopwatch, tape</a:t>
                       </a:r>
                     </a:p>
                   </a:txBody>
@@ -6038,7 +6038,7 @@
                           </a:solidFill>
                           <a:latin typeface="ITC Avant Garde Gothic"/>
                         </a:rPr>
-                        <a:t>Calibration</a:t>
+                        <a:t>Health check</a:t>
                       </a:r>
                     </a:p>
                   </a:txBody>
@@ -6082,7 +6082,7 @@
                           </a:solidFill>
                           <a:latin typeface="ITC Avant Garde Gothic"/>
                         </a:rPr>
-                        <a:t>10 volunteers</a:t>
+                        <a:t>10 + ____ volunteers</a:t>
                       </a:r>
                     </a:p>
                   </a:txBody>
@@ -6128,7 +6128,7 @@
                           </a:solidFill>
                           <a:latin typeface="ITC Avant Garde Gothic"/>
                         </a:rPr>
-                        <a:t>Validation</a:t>
+                        <a:t>Falls</a:t>
                       </a:r>
                     </a:p>
                   </a:txBody>
@@ -6150,7 +6150,7 @@
                           </a:solidFill>
                           <a:latin typeface="ITC Avant Garde Gothic"/>
                         </a:rPr>
-                        <a:t>Temperature, PR, SpO₂, time</a:t>
+                        <a:t>Pendant decision, alert time</a:t>
                       </a:r>
                     </a:p>
                   </a:txBody>
@@ -6172,7 +6172,7 @@
                           </a:solidFill>
                           <a:latin typeface="ITC Avant Garde Gothic"/>
                         </a:rPr>
-                        <a:t>____ volunteers</a:t>
+                        <a:t>____ falls; ____ activities</a:t>
                       </a:r>
                     </a:p>
                   </a:txBody>
@@ -6194,7 +6194,7 @@
                           </a:solidFill>
                           <a:latin typeface="ITC Avant Garde Gothic"/>
                         </a:rPr>
-                        <a:t>Clinic instruments</a:t>
+                        <a:t>Video</a:t>
                       </a:r>
                     </a:p>
                   </a:txBody>
@@ -6218,7 +6218,7 @@
                           </a:solidFill>
                           <a:latin typeface="ITC Avant Garde Gothic"/>
                         </a:rPr>
-                        <a:t>Logic + usability</a:t>
+                        <a:t>Reminders, usability</a:t>
                       </a:r>
                     </a:p>
                   </a:txBody>
@@ -6240,7 +6240,7 @@
                           </a:solidFill>
                           <a:latin typeface="ITC Avant Garde Gothic"/>
                         </a:rPr>
-                        <a:t>Flags; SUS; approachability</a:t>
+                        <a:t>On time; delivered; SUS; rating</a:t>
                       </a:r>
                     </a:p>
                   </a:txBody>
@@ -6262,7 +6262,7 @@
                           </a:solidFill>
                           <a:latin typeface="ITC Avant Garde Gothic"/>
                         </a:rPr>
-                        <a:t>60 cases; ____ users</a:t>
+                        <a:t>5 days; ____ users</a:t>
                       </a:r>
                     </a:p>
                   </a:txBody>
@@ -6284,7 +6284,7 @@
                           </a:solidFill>
                           <a:latin typeface="ITC Avant Garde Gothic"/>
                         </a:rPr>
-                        <a:t>Limits; soft vs rigid</a:t>
+                        <a:t>Phone time stamps</a:t>
                       </a:r>
                     </a:p>
                   </a:txBody>
@@ -6633,7 +6633,7 @@
                 </a:solidFill>
                 <a:latin typeface="ITC Avant Garde Gothic"/>
               </a:rPr>
-              <a:t>This is a quantitative developmental and method-comparison study. The robot is built and calibrated first; then its readings are compared with reference instruments, and users rate it.</a:t>
+              <a:t>This is a quantitative developmental study with method-comparison, experimental, and usability tests. The robot is built and calibrated first; then it is tested in a mock home.</a:t>
             </a:r>
           </a:p>
         </p:txBody>
@@ -6878,7 +6878,7 @@
                 </a:solidFill>
                 <a:latin typeface="ITC Avant Garde Gothic"/>
               </a:rPr>
-              <a:t>3. Screen volunteers</a:t>
+              <a:t>3. Run the trials</a:t>
             </a:r>
           </a:p>
         </p:txBody>
@@ -7122,7 +7122,7 @@
                           </a:solidFill>
                           <a:latin typeface="ITC Avant Garde Gothic"/>
                         </a:rPr>
-                        <a:t>Measurement method (ALAGA; reference)</a:t>
+                        <a:t>Target station; obstacle</a:t>
                       </a:r>
                     </a:p>
                     <a:p>
@@ -7133,7 +7133,7 @@
                           </a:solidFill>
                           <a:latin typeface="ITC Avant Garde Gothic"/>
                         </a:rPr>
-                        <a:t>Target temperature (°C)</a:t>
+                        <a:t>Method (ALAGA; reference)</a:t>
                       </a:r>
                     </a:p>
                     <a:p>
@@ -7144,7 +7144,18 @@
                           </a:solidFill>
                           <a:latin typeface="ITC Avant Garde Gothic"/>
                         </a:rPr>
-                        <a:t>Body type (soft; rigid)</a:t>
+                        <a:t>Event (fall; daily activity)</a:t>
+                      </a:r>
+                    </a:p>
+                    <a:p>
+                      <a:r>
+                        <a:rPr sz="1500" b="0">
+                          <a:solidFill>
+                            <a:srgbClr val="2B2020"/>
+                          </a:solidFill>
+                          <a:latin typeface="ITC Avant Garde Gothic"/>
+                        </a:rPr>
+                        <a:t>Body (soft; rigid)</a:t>
                       </a:r>
                     </a:p>
                   </a:txBody>
@@ -7166,7 +7177,7 @@
                           </a:solidFill>
                           <a:latin typeface="ITC Avant Garde Gothic"/>
                         </a:rPr>
-                        <a:t>Bias, LoA, MAE, Arms</a:t>
+                        <a:t>Arrival rate, stop distance</a:t>
                       </a:r>
                     </a:p>
                     <a:p>
@@ -7177,7 +7188,7 @@
                           </a:solidFill>
                           <a:latin typeface="ITC Avant Garde Gothic"/>
                         </a:rPr>
-                        <a:t>Sensitivity, specificity</a:t>
+                        <a:t>Bias, LoA, Arms</a:t>
                       </a:r>
                     </a:p>
                     <a:p>
@@ -7188,7 +7199,18 @@
                           </a:solidFill>
                           <a:latin typeface="ITC Avant Garde Gothic"/>
                         </a:rPr>
-                        <a:t>Screening time; SUS; approachability</a:t>
+                        <a:t>Sensitivity, specificity, alert time</a:t>
+                      </a:r>
+                    </a:p>
+                    <a:p>
+                      <a:r>
+                        <a:rPr sz="1500" b="0">
+                          <a:solidFill>
+                            <a:srgbClr val="2B2020"/>
+                          </a:solidFill>
+                          <a:latin typeface="ITC Avant Garde Gothic"/>
+                        </a:rPr>
+                        <a:t>SUS; approachability</a:t>
                       </a:r>
                     </a:p>
                   </a:txBody>
@@ -7210,6 +7232,17 @@
                           </a:solidFill>
                           <a:latin typeface="ITC Avant Garde Gothic"/>
                         </a:rPr>
+                        <a:t>Tape route, speed 0.2 m/s</a:t>
+                      </a:r>
+                    </a:p>
+                    <a:p>
+                      <a:r>
+                        <a:rPr sz="1500" b="0">
+                          <a:solidFill>
+                            <a:srgbClr val="2B2020"/>
+                          </a:solidFill>
+                          <a:latin typeface="ITC Avant Garde Gothic"/>
+                        </a:rPr>
                         <a:t>Room 26–30 °C; 5-min rest</a:t>
                       </a:r>
                     </a:p>
@@ -7221,7 +7254,7 @@
                           </a:solidFill>
                           <a:latin typeface="ITC Avant Garde Gothic"/>
                         </a:rPr>
-                        <a:t>Forehead 3–5 cm; left index finger</a:t>
+                        <a:t>Pendant at the chest</a:t>
                       </a:r>
                     </a:p>
                     <a:p>
@@ -7666,7 +7699,7 @@
                 </a:solidFill>
                 <a:latin typeface="ITC Avant Garde Gothic"/>
               </a:rPr>
-              <a:t>•  Body: white ripstop nylon, about 1.1 m tall, kept inflated by a 12 V blower fan in the base.</a:t>
+              <a:t>•  Body: white ripstop nylon, about 1.35 m tall in all, kept inflated by a 12 V blower fan.</a:t>
             </a:r>
           </a:p>
           <a:p>
@@ -7682,7 +7715,7 @@
                 </a:solidFill>
                 <a:latin typeface="ITC Avant Garde Gothic"/>
               </a:rPr>
-              <a:t>•  Chest panel: MLX90614 and HC-SR04 at forehead height; MAX30102 finger cradle.</a:t>
+              <a:t>•  Base: 40 × 40 cm plywood, 2 geared motors with 65-mm wheels, front caster, top speed 0.2 m/s.</a:t>
             </a:r>
           </a:p>
           <a:p>
@@ -7698,7 +7731,7 @@
                 </a:solidFill>
                 <a:latin typeface="ITC Avant Garde Gothic"/>
               </a:rPr>
-              <a:t>•  Controls: 0–10 pain dial, chest button, and a sound sensor that wakes ALAGA.</a:t>
+              <a:t>•  Front: 5-channel line sensor, HC-SR04, bumper. Chest: thermometer, finger slot, dial, button, OLED.</a:t>
             </a:r>
           </a:p>
           <a:p>
@@ -7714,7 +7747,7 @@
                 </a:solidFill>
                 <a:latin typeface="ITC Avant Garde Gothic"/>
               </a:rPr>
-              <a:t>•  Voice and display: DFPlayer Mini with 3 W speaker; 0.96-in OLED on the chest.</a:t>
+              <a:t>•  ESP32 with Telegram over Wi-Fi and ESP-NOW for the pendant; 12 V 7 Ah battery.</a:t>
             </a:r>
           </a:p>
           <a:p>
@@ -7730,7 +7763,7 @@
                 </a:solidFill>
                 <a:latin typeface="ITC Avant Garde Gothic"/>
               </a:rPr>
-              <a:t>•  Controller and power: ESP32 state machine; 12 V 7 Ah battery, 5 V regulator; CSV log.</a:t>
+              <a:t>•  Pendant: ESP32-C3, MPU6050, buzzer, SOS button, 400 mAh battery on a neck cord.</a:t>
             </a:r>
           </a:p>
         </p:txBody>
@@ -8014,6 +8047,142 @@
                           </a:solidFill>
                           <a:latin typeface="ITC Avant Garde Gothic"/>
                         </a:rPr>
+                        <a:t>12 V geared motors with 65-mm wheels; caster</a:t>
+                      </a:r>
+                    </a:p>
+                  </a:txBody>
+                  <a:tcPr>
+                    <a:solidFill>
+                      <a:srgbClr val="FFFFFF"/>
+                    </a:solidFill>
+                  </a:tcPr>
+                </a:tc>
+                <a:tc>
+                  <a:txBody>
+                    <a:bodyPr/>
+                    <a:lstStyle/>
+                    <a:p>
+                      <a:r>
+                        <a:rPr sz="1200" b="0">
+                          <a:solidFill>
+                            <a:srgbClr val="2B2020"/>
+                          </a:solidFill>
+                          <a:latin typeface="ITC Avant Garde Gothic"/>
+                        </a:rPr>
+                        <a:t>2; 1</a:t>
+                      </a:r>
+                    </a:p>
+                  </a:txBody>
+                  <a:tcPr>
+                    <a:solidFill>
+                      <a:srgbClr val="FFFFFF"/>
+                    </a:solidFill>
+                  </a:tcPr>
+                </a:tc>
+                <a:tc>
+                  <a:txBody>
+                    <a:bodyPr/>
+                    <a:lstStyle/>
+                    <a:p>
+                      <a:r>
+                        <a:rPr sz="1200" b="0">
+                          <a:solidFill>
+                            <a:srgbClr val="2B2020"/>
+                          </a:solidFill>
+                          <a:latin typeface="ITC Avant Garde Gothic"/>
+                        </a:rPr>
+                        <a:t>Two-wheel-drive base</a:t>
+                      </a:r>
+                    </a:p>
+                  </a:txBody>
+                  <a:tcPr>
+                    <a:solidFill>
+                      <a:srgbClr val="FFFFFF"/>
+                    </a:solidFill>
+                  </a:tcPr>
+                </a:tc>
+              </a:tr>
+              <a:tr h="502920">
+                <a:tc>
+                  <a:txBody>
+                    <a:bodyPr/>
+                    <a:lstStyle/>
+                    <a:p>
+                      <a:r>
+                        <a:rPr sz="1200" b="0">
+                          <a:solidFill>
+                            <a:srgbClr val="8B0707"/>
+                          </a:solidFill>
+                          <a:latin typeface="ITC Avant Garde Gothic"/>
+                        </a:rPr>
+                        <a:t>L298N driver; 5-channel line sensor; bumper</a:t>
+                      </a:r>
+                    </a:p>
+                  </a:txBody>
+                  <a:tcPr>
+                    <a:solidFill>
+                      <a:srgbClr val="F8EAEA"/>
+                    </a:solidFill>
+                  </a:tcPr>
+                </a:tc>
+                <a:tc>
+                  <a:txBody>
+                    <a:bodyPr/>
+                    <a:lstStyle/>
+                    <a:p>
+                      <a:r>
+                        <a:rPr sz="1200" b="0">
+                          <a:solidFill>
+                            <a:srgbClr val="2B2020"/>
+                          </a:solidFill>
+                          <a:latin typeface="ITC Avant Garde Gothic"/>
+                        </a:rPr>
+                        <a:t>1 each</a:t>
+                      </a:r>
+                    </a:p>
+                  </a:txBody>
+                  <a:tcPr>
+                    <a:solidFill>
+                      <a:srgbClr val="F8EAEA"/>
+                    </a:solidFill>
+                  </a:tcPr>
+                </a:tc>
+                <a:tc>
+                  <a:txBody>
+                    <a:bodyPr/>
+                    <a:lstStyle/>
+                    <a:p>
+                      <a:r>
+                        <a:rPr sz="1200" b="0">
+                          <a:solidFill>
+                            <a:srgbClr val="2B2020"/>
+                          </a:solidFill>
+                          <a:latin typeface="ITC Avant Garde Gothic"/>
+                        </a:rPr>
+                        <a:t>Driving and route following</a:t>
+                      </a:r>
+                    </a:p>
+                  </a:txBody>
+                  <a:tcPr>
+                    <a:solidFill>
+                      <a:srgbClr val="F8EAEA"/>
+                    </a:solidFill>
+                  </a:tcPr>
+                </a:tc>
+              </a:tr>
+              <a:tr h="502920">
+                <a:tc>
+                  <a:txBody>
+                    <a:bodyPr/>
+                    <a:lstStyle/>
+                    <a:p>
+                      <a:r>
+                        <a:rPr sz="1200" b="0">
+                          <a:solidFill>
+                            <a:srgbClr val="8B0707"/>
+                          </a:solidFill>
+                          <a:latin typeface="ITC Avant Garde Gothic"/>
+                        </a:rPr>
                         <a:t>ESP32 development board</a:t>
                       </a:r>
                     </a:p>
@@ -8058,7 +8227,7 @@
                           </a:solidFill>
                           <a:latin typeface="ITC Avant Garde Gothic"/>
                         </a:rPr>
-                        <a:t>Controller</a:t>
+                        <a:t>Controller, Wi-Fi, ESP-NOW</a:t>
                       </a:r>
                     </a:p>
                   </a:txBody>
@@ -8082,7 +8251,7 @@
                           </a:solidFill>
                           <a:latin typeface="ITC Avant Garde Gothic"/>
                         </a:rPr>
-                        <a:t>MLX90614 (GY-906) infrared thermometer</a:t>
+                        <a:t>MLX90614; MAX30102</a:t>
                       </a:r>
                     </a:p>
                   </a:txBody>
@@ -8104,7 +8273,7 @@
                           </a:solidFill>
                           <a:latin typeface="ITC Avant Garde Gothic"/>
                         </a:rPr>
-                        <a:t>1</a:t>
+                        <a:t>1 each</a:t>
                       </a:r>
                     </a:p>
                   </a:txBody>
@@ -8126,7 +8295,7 @@
                           </a:solidFill>
                           <a:latin typeface="ITC Avant Garde Gothic"/>
                         </a:rPr>
-                        <a:t>Forehead temperature</a:t>
+                        <a:t>Temperature, pulse rate, SpO₂</a:t>
                       </a:r>
                     </a:p>
                   </a:txBody>
@@ -8150,7 +8319,7 @@
                           </a:solidFill>
                           <a:latin typeface="ITC Avant Garde Gothic"/>
                         </a:rPr>
-                        <a:t>MAX30102 pulse oximeter module</a:t>
+                        <a:t>HC-SR04 ultrasonic sensor</a:t>
                       </a:r>
                     </a:p>
                   </a:txBody>
@@ -8194,7 +8363,7 @@
                           </a:solidFill>
                           <a:latin typeface="ITC Avant Garde Gothic"/>
                         </a:rPr>
-                        <a:t>Pulse rate and SpO₂</a:t>
+                        <a:t>Obstacle detection</a:t>
                       </a:r>
                     </a:p>
                   </a:txBody>
@@ -8218,143 +8387,7 @@
                           </a:solidFill>
                           <a:latin typeface="ITC Avant Garde Gothic"/>
                         </a:rPr>
-                        <a:t>HC-SR04 ultrasonic sensor</a:t>
-                      </a:r>
-                    </a:p>
-                  </a:txBody>
-                  <a:tcPr>
-                    <a:solidFill>
-                      <a:srgbClr val="F8EAEA"/>
-                    </a:solidFill>
-                  </a:tcPr>
-                </a:tc>
-                <a:tc>
-                  <a:txBody>
-                    <a:bodyPr/>
-                    <a:lstStyle/>
-                    <a:p>
-                      <a:r>
-                        <a:rPr sz="1200" b="0">
-                          <a:solidFill>
-                            <a:srgbClr val="2B2020"/>
-                          </a:solidFill>
-                          <a:latin typeface="ITC Avant Garde Gothic"/>
-                        </a:rPr>
-                        <a:t>1</a:t>
-                      </a:r>
-                    </a:p>
-                  </a:txBody>
-                  <a:tcPr>
-                    <a:solidFill>
-                      <a:srgbClr val="F8EAEA"/>
-                    </a:solidFill>
-                  </a:tcPr>
-                </a:tc>
-                <a:tc>
-                  <a:txBody>
-                    <a:bodyPr/>
-                    <a:lstStyle/>
-                    <a:p>
-                      <a:r>
-                        <a:rPr sz="1200" b="0">
-                          <a:solidFill>
-                            <a:srgbClr val="2B2020"/>
-                          </a:solidFill>
-                          <a:latin typeface="ITC Avant Garde Gothic"/>
-                        </a:rPr>
-                        <a:t>Forehead distance check</a:t>
-                      </a:r>
-                    </a:p>
-                  </a:txBody>
-                  <a:tcPr>
-                    <a:solidFill>
-                      <a:srgbClr val="F8EAEA"/>
-                    </a:solidFill>
-                  </a:tcPr>
-                </a:tc>
-              </a:tr>
-              <a:tr h="502920">
-                <a:tc>
-                  <a:txBody>
-                    <a:bodyPr/>
-                    <a:lstStyle/>
-                    <a:p>
-                      <a:r>
-                        <a:rPr sz="1200" b="0">
-                          <a:solidFill>
-                            <a:srgbClr val="8B0707"/>
-                          </a:solidFill>
-                          <a:latin typeface="ITC Avant Garde Gothic"/>
-                        </a:rPr>
-                        <a:t>0.96-in OLED display (SSD1306)</a:t>
-                      </a:r>
-                    </a:p>
-                  </a:txBody>
-                  <a:tcPr>
-                    <a:solidFill>
-                      <a:srgbClr val="FFFFFF"/>
-                    </a:solidFill>
-                  </a:tcPr>
-                </a:tc>
-                <a:tc>
-                  <a:txBody>
-                    <a:bodyPr/>
-                    <a:lstStyle/>
-                    <a:p>
-                      <a:r>
-                        <a:rPr sz="1200" b="0">
-                          <a:solidFill>
-                            <a:srgbClr val="2B2020"/>
-                          </a:solidFill>
-                          <a:latin typeface="ITC Avant Garde Gothic"/>
-                        </a:rPr>
-                        <a:t>1</a:t>
-                      </a:r>
-                    </a:p>
-                  </a:txBody>
-                  <a:tcPr>
-                    <a:solidFill>
-                      <a:srgbClr val="FFFFFF"/>
-                    </a:solidFill>
-                  </a:tcPr>
-                </a:tc>
-                <a:tc>
-                  <a:txBody>
-                    <a:bodyPr/>
-                    <a:lstStyle/>
-                    <a:p>
-                      <a:r>
-                        <a:rPr sz="1200" b="0">
-                          <a:solidFill>
-                            <a:srgbClr val="2B2020"/>
-                          </a:solidFill>
-                          <a:latin typeface="ITC Avant Garde Gothic"/>
-                        </a:rPr>
-                        <a:t>Chest display</a:t>
-                      </a:r>
-                    </a:p>
-                  </a:txBody>
-                  <a:tcPr>
-                    <a:solidFill>
-                      <a:srgbClr val="FFFFFF"/>
-                    </a:solidFill>
-                  </a:tcPr>
-                </a:tc>
-              </a:tr>
-              <a:tr h="502920">
-                <a:tc>
-                  <a:txBody>
-                    <a:bodyPr/>
-                    <a:lstStyle/>
-                    <a:p>
-                      <a:r>
-                        <a:rPr sz="1200" b="0">
-                          <a:solidFill>
-                            <a:srgbClr val="8B0707"/>
-                          </a:solidFill>
-                          <a:latin typeface="ITC Avant Garde Gothic"/>
-                        </a:rPr>
-                        <a:t>DFPlayer Mini, microSD card, 3 W speaker</a:t>
+                        <a:t>OLED; DFPlayer Mini, microSD, 3 W speaker</a:t>
                       </a:r>
                     </a:p>
                   </a:txBody>
@@ -8398,7 +8431,7 @@
                           </a:solidFill>
                           <a:latin typeface="ITC Avant Garde Gothic"/>
                         </a:rPr>
-                        <a:t>Spoken prompts</a:t>
+                        <a:t>Display and voice</a:t>
                       </a:r>
                     </a:p>
                   </a:txBody>
@@ -8422,7 +8455,7 @@
                           </a:solidFill>
                           <a:latin typeface="ITC Avant Garde Gothic"/>
                         </a:rPr>
-                        <a:t>KY-037 sound sensor, push button, 10 kΩ dial</a:t>
+                        <a:t>KY-037 sound sensor, button, 10 kΩ dial</a:t>
                       </a:r>
                     </a:p>
                   </a:txBody>
@@ -8466,7 +8499,7 @@
                           </a:solidFill>
                           <a:latin typeface="ITC Avant Garde Gothic"/>
                         </a:rPr>
-                        <a:t>Wake-up and pain score</a:t>
+                        <a:t>Calling, confirming, choosing</a:t>
                       </a:r>
                     </a:p>
                   </a:txBody>
@@ -8490,7 +8523,7 @@
                           </a:solidFill>
                           <a:latin typeface="ITC Avant Garde Gothic"/>
                         </a:rPr>
-                        <a:t>12 V 7 Ah SLA battery, LM2596 regulator, fuse</a:t>
+                        <a:t>12 V 7 Ah battery, LM2596, D4184, fuse</a:t>
                       </a:r>
                     </a:p>
                   </a:txBody>
@@ -8534,7 +8567,7 @@
                           </a:solidFill>
                           <a:latin typeface="ITC Avant Garde Gothic"/>
                         </a:rPr>
-                        <a:t>Power</a:t>
+                        <a:t>Power and fan switch</a:t>
                       </a:r>
                     </a:p>
                   </a:txBody>
@@ -8558,7 +8591,7 @@
                           </a:solidFill>
                           <a:latin typeface="ITC Avant Garde Gothic"/>
                         </a:rPr>
-                        <a:t>D4184 MOSFET module, wires, perfboard</a:t>
+                        <a:t>Pendant: ESP32-C3, MPU6050, buzzer, LiPo</a:t>
                       </a:r>
                     </a:p>
                   </a:txBody>
@@ -8602,7 +8635,7 @@
                           </a:solidFill>
                           <a:latin typeface="ITC Avant Garde Gothic"/>
                         </a:rPr>
-                        <a:t>Fan switch and wiring</a:t>
+                        <a:t>Fall detection and SOS</a:t>
                       </a:r>
                     </a:p>
                   </a:txBody>
@@ -8626,7 +8659,7 @@
                           </a:solidFill>
                           <a:latin typeface="ITC Avant Garde Gothic"/>
                         </a:rPr>
-                        <a:t>Reference forehead thermometer and pulse oximeter</a:t>
+                        <a:t>Reference thermometer and pulse oximeter</a:t>
                       </a:r>
                     </a:p>
                   </a:txBody>
@@ -9275,7 +9308,7 @@
                 </a:solidFill>
                 <a:latin typeface="ITC Avant Garde Gothic"/>
               </a:rPr>
-              <a:t>Sew and seal the body</a:t>
+              <a:t>Sew body; build wheeled base</a:t>
             </a:r>
           </a:p>
         </p:txBody>
@@ -9442,7 +9475,7 @@
                 </a:solidFill>
                 <a:latin typeface="ITC Avant Garde Gothic"/>
               </a:rPr>
-              <a:t>Wire sensors, audio, fan</a:t>
+              <a:t>Wire robot and pendant</a:t>
             </a:r>
           </a:p>
         </p:txBody>
@@ -9609,7 +9642,7 @@
                 </a:solidFill>
                 <a:latin typeface="ITC Avant Garde Gothic"/>
               </a:rPr>
-              <a:t>Program state machine</a:t>
+              <a:t>Program tasks and alerts</a:t>
             </a:r>
           </a:p>
         </p:txBody>
@@ -9776,7 +9809,7 @@
                 </a:solidFill>
                 <a:latin typeface="ITC Avant Garde Gothic"/>
               </a:rPr>
-              <a:t>Bench-test IR in water bath</a:t>
+              <a:t>Tape the mock-home route</a:t>
             </a:r>
           </a:p>
         </p:txBody>
@@ -9900,7 +9933,7 @@
                 </a:solidFill>
                 <a:latin typeface="ITC Avant Garde Gothic"/>
               </a:rPr>
-              <a:t>Calibrate on 10 volunteers</a:t>
+              <a:t>Calibrate sensors, fall rule</a:t>
             </a:r>
           </a:p>
         </p:txBody>
@@ -10067,7 +10100,7 @@
                 </a:solidFill>
                 <a:latin typeface="ITC Avant Garde Gothic"/>
               </a:rPr>
-              <a:t>Screen validation volunteers</a:t>
+              <a:t>Navigation and health trials</a:t>
             </a:r>
           </a:p>
         </p:txBody>
@@ -10234,7 +10267,7 @@
                 </a:solidFill>
                 <a:latin typeface="ITC Avant Garde Gothic"/>
               </a:rPr>
-              <a:t>Run 60 logic test cases</a:t>
+              <a:t>Simulated falls, activities</a:t>
             </a:r>
           </a:p>
         </p:txBody>
@@ -10401,7 +10434,7 @@
                 </a:solidFill>
                 <a:latin typeface="ITC Avant Garde Gothic"/>
               </a:rPr>
-              <a:t>Usability: soft vs rigid</a:t>
+              <a:t>Reminders; usability test</a:t>
             </a:r>
           </a:p>
         </p:txBody>
@@ -10568,7 +10601,7 @@
                 </a:solidFill>
                 <a:latin typeface="ITC Avant Garde Gothic"/>
               </a:rPr>
-              <a:t>Bland–Altman, t-test, Wilcoxon</a:t>
+              <a:t>Bland–Altman, χ², t, Wilcoxon</a:t>
             </a:r>
           </a:p>
         </p:txBody>
@@ -11031,7 +11064,7 @@
                 </a:solidFill>
                 <a:latin typeface="ITC Avant Garde Gothic"/>
               </a:rPr>
-              <a:t>d = ALAGA − reference</a:t>
+              <a:t>Success = correct ÷ trips × 100</a:t>
             </a:r>
           </a:p>
         </p:txBody>
@@ -11070,7 +11103,7 @@
                 </a:solidFill>
                 <a:latin typeface="ITC Avant Garde Gothic"/>
               </a:rPr>
-              <a:t>difference per paired reading</a:t>
+              <a:t>navigation reliability (%)</a:t>
             </a:r>
           </a:p>
         </p:txBody>
@@ -11148,7 +11181,7 @@
                 </a:solidFill>
                 <a:latin typeface="ITC Avant Garde Gothic"/>
               </a:rPr>
-              <a:t>mean bias, 95% limits of agreement</a:t>
+              <a:t>d = ALAGA − reference</a:t>
             </a:r>
           </a:p>
         </p:txBody>
@@ -11265,7 +11298,7 @@
                 </a:solidFill>
                 <a:latin typeface="ITC Avant Garde Gothic"/>
               </a:rPr>
-              <a:t>Sensitivity = TP ÷ (TP + FN)</a:t>
+              <a:t>Sens. = TP ÷ (TP + FN); Spec. = TN ÷ (TN + FP)</a:t>
             </a:r>
           </a:p>
         </p:txBody>
@@ -11304,7 +11337,7 @@
                 </a:solidFill>
                 <a:latin typeface="ITC Avant Garde Gothic"/>
               </a:rPr>
-              <a:t>flags correctly raised</a:t>
+              <a:t>falls detected; activities ignored</a:t>
             </a:r>
           </a:p>
         </p:txBody>
@@ -11343,7 +11376,7 @@
                 </a:solidFill>
                 <a:latin typeface="ITC Avant Garde Gothic"/>
               </a:rPr>
-              <a:t>Specificity = TN ÷ (TN + FP)</a:t>
+              <a:t>t_alert = t_phone − t_event</a:t>
             </a:r>
           </a:p>
         </p:txBody>
@@ -11382,7 +11415,7 @@
                 </a:solidFill>
                 <a:latin typeface="ITC Avant Garde Gothic"/>
               </a:rPr>
-              <a:t>normal results correctly passed</a:t>
+              <a:t>alert time (s)</a:t>
             </a:r>
           </a:p>
         </p:txBody>
@@ -11552,7 +11585,7 @@
                           </a:solidFill>
                           <a:latin typeface="ITC Avant Garde Gothic"/>
                         </a:rPr>
-                        <a:t>Agreement with reference instruments</a:t>
+                        <a:t>Navigation</a:t>
                       </a:r>
                     </a:p>
                   </a:txBody>
@@ -11574,7 +11607,7 @@
                           </a:solidFill>
                           <a:latin typeface="ITC Avant Garde Gothic"/>
                         </a:rPr>
-                        <a:t>Bias, LoA, MAE, Arms; paired t-test</a:t>
+                        <a:t>Success rate; mean ± SD</a:t>
                       </a:r>
                     </a:p>
                   </a:txBody>
@@ -11620,7 +11653,7 @@
                           </a:solidFill>
                           <a:latin typeface="ITC Avant Garde Gothic"/>
                         </a:rPr>
-                        <a:t>Accuracy of flags</a:t>
+                        <a:t>Agreement with reference</a:t>
                       </a:r>
                     </a:p>
                   </a:txBody>
@@ -11642,7 +11675,7 @@
                           </a:solidFill>
                           <a:latin typeface="ITC Avant Garde Gothic"/>
                         </a:rPr>
-                        <a:t>Confusion matrix; sensitivity, specificity</a:t>
+                        <a:t>Bias, LoA, Arms; paired t-test</a:t>
                       </a:r>
                     </a:p>
                   </a:txBody>
@@ -11688,7 +11721,7 @@
                           </a:solidFill>
                           <a:latin typeface="ITC Avant Garde Gothic"/>
                         </a:rPr>
-                        <a:t>Screening time</a:t>
+                        <a:t>Falls and alerts</a:t>
                       </a:r>
                     </a:p>
                   </a:txBody>
@@ -11710,7 +11743,7 @@
                           </a:solidFill>
                           <a:latin typeface="ITC Avant Garde Gothic"/>
                         </a:rPr>
-                        <a:t>Mean ± SD</a:t>
+                        <a:t>Sensitivity, specificity; χ²</a:t>
                       </a:r>
                     </a:p>
                   </a:txBody>
@@ -11756,7 +11789,7 @@
                           </a:solidFill>
                           <a:latin typeface="ITC Avant Garde Gothic"/>
                         </a:rPr>
-                        <a:t>Usability and approachability</a:t>
+                        <a:t>Reminders and messages</a:t>
                       </a:r>
                     </a:p>
                   </a:txBody>
@@ -11778,7 +11811,7 @@
                           </a:solidFill>
                           <a:latin typeface="ITC Avant Garde Gothic"/>
                         </a:rPr>
-                        <a:t>SUS; Wilcoxon signed-rank</a:t>
+                        <a:t>Punctuality; delivery rate</a:t>
                       </a:r>
                     </a:p>
                   </a:txBody>
@@ -11824,7 +11857,75 @@
                           </a:solidFill>
                           <a:latin typeface="ITC Avant Garde Gothic"/>
                         </a:rPr>
-                        <a:t>Cost to build and run</a:t>
+                        <a:t>Usability, approachability</a:t>
+                      </a:r>
+                    </a:p>
+                  </a:txBody>
+                  <a:tcPr>
+                    <a:solidFill>
+                      <a:srgbClr val="FFFFFF"/>
+                    </a:solidFill>
+                  </a:tcPr>
+                </a:tc>
+                <a:tc>
+                  <a:txBody>
+                    <a:bodyPr/>
+                    <a:lstStyle/>
+                    <a:p>
+                      <a:r>
+                        <a:rPr sz="1200" b="0">
+                          <a:solidFill>
+                            <a:srgbClr val="2B2020"/>
+                          </a:solidFill>
+                          <a:latin typeface="ITC Avant Garde Gothic"/>
+                        </a:rPr>
+                        <a:t>SUS; Wilcoxon signed-rank</a:t>
+                      </a:r>
+                    </a:p>
+                  </a:txBody>
+                  <a:tcPr>
+                    <a:solidFill>
+                      <a:srgbClr val="FFFFFF"/>
+                    </a:solidFill>
+                  </a:tcPr>
+                </a:tc>
+              </a:tr>
+              <a:tr h="1188720">
+                <a:tc>
+                  <a:txBody>
+                    <a:bodyPr/>
+                    <a:lstStyle/>
+                    <a:p>
+                      <a:r>
+                        <a:rPr sz="1200" b="0">
+                          <a:solidFill>
+                            <a:srgbClr val="8B0707"/>
+                          </a:solidFill>
+                          <a:latin typeface="ITC Avant Garde Gothic"/>
+                        </a:rPr>
+                        <a:t>S6</a:t>
+                      </a:r>
+                    </a:p>
+                  </a:txBody>
+                  <a:tcPr>
+                    <a:solidFill>
+                      <a:srgbClr val="FFFFFF"/>
+                    </a:solidFill>
+                  </a:tcPr>
+                </a:tc>
+                <a:tc>
+                  <a:txBody>
+                    <a:bodyPr/>
+                    <a:lstStyle/>
+                    <a:p>
+                      <a:r>
+                        <a:rPr sz="1200" b="0">
+                          <a:solidFill>
+                            <a:srgbClr val="2B2020"/>
+                          </a:solidFill>
+                          <a:latin typeface="ITC Avant Garde Gothic"/>
+                        </a:rPr>
+                        <a:t>Cost</a:t>
                       </a:r>
                     </a:p>
                   </a:txBody>
@@ -12305,7 +12406,7 @@
                 </a:solidFill>
                 <a:latin typeface="ITC Avant Garde Gothic"/>
               </a:rPr>
-              <a:t>Human participants: plan approved by the school IRB before testing (ISEF Form 4).</a:t>
+              <a:t>Plan approved by the school IRB first; consent from every participant (ISEF Form 4).</a:t>
             </a:r>
           </a:p>
           <a:p>
@@ -12321,7 +12422,7 @@
                 </a:solidFill>
                 <a:latin typeface="ITC Avant Garde Gothic"/>
               </a:rPr>
-              <a:t>Informed consent; assent and parent consent for minors; may stop anytime.</a:t>
+              <a:t>Older adults only do seated health checks and usability sessions.</a:t>
             </a:r>
           </a:p>
           <a:p>
@@ -12337,7 +12438,7 @@
                 </a:solidFill>
                 <a:latin typeface="ITC Avant Garde Gothic"/>
               </a:rPr>
-              <a:t>Non-invasive only; codes, not names; flagged readings referred to the nurse.</a:t>
+              <a:t>Falls simulated only by researchers on 20-cm gym mats, with pads and supervision.</a:t>
             </a:r>
           </a:p>
           <a:p>
@@ -12353,7 +12454,7 @@
                 </a:solidFill>
                 <a:latin typeface="ITC Avant Garde Gothic"/>
               </a:rPr>
-              <a:t>ALAGA screens and refers; it gives no diagnosis. No data were fabricated.</a:t>
+              <a:t>Private family Telegram group; coded data. ALAGA never diagnoses.</a:t>
             </a:r>
           </a:p>
         </p:txBody>
@@ -12452,7 +12553,7 @@
                 </a:solidFill>
                 <a:latin typeface="ITC Avant Garde Gothic"/>
               </a:rPr>
-              <a:t>Blower fan: metal finger guard; fan sealed inside the base.</a:t>
+              <a:t>Moving robot: 0.2 m/s top speed, soft body, bumper and ultrasonic stop.</a:t>
             </a:r>
           </a:p>
           <a:p>
@@ -12468,7 +12569,7 @@
                 </a:solidFill>
                 <a:latin typeface="ITC Avant Garde Gothic"/>
               </a:rPr>
-              <a:t>12 V battery: inline fuse; wiring in a closed box; supervised charging.</a:t>
+              <a:t>Fan and wheels: finger guard; wheels inside the base outline.</a:t>
             </a:r>
           </a:p>
           <a:p>
@@ -12484,7 +12585,7 @@
                 </a:solidFill>
                 <a:latin typeface="ITC Avant Garde Gothic"/>
               </a:rPr>
-              <a:t>Shared sensors: wiped with 70% alcohol between volunteers.</a:t>
+              <a:t>12 V battery: inline fuse; wiring in a closed box; supervised charging.</a:t>
             </a:r>
           </a:p>
           <a:p>
@@ -12500,7 +12601,7 @@
                 </a:solidFill>
                 <a:latin typeface="ITC Avant Garde Gothic"/>
               </a:rPr>
-              <a:t>Wrong reading: reference taken for every volunteer; nurse referral.</a:t>
+              <a:t>Shared sensors: wiped with 70% alcohol between participants.</a:t>
             </a:r>
           </a:p>
           <a:p>
@@ -12516,7 +12617,7 @@
                 </a:solidFill>
                 <a:latin typeface="ITC Avant Garde Gothic"/>
               </a:rPr>
-              <a:t>Personal data: password-protected and deleted after the fair.</a:t>
+              <a:t>No data were fabricated; all sources cited in APA 7th edition.</a:t>
             </a:r>
           </a:p>
         </p:txBody>
@@ -13528,7 +13629,7 @@
                 </a:solidFill>
                 <a:latin typeface="ITC Avant Garde Gothic"/>
               </a:rPr>
-              <a:t>•  Mayon was raised to Alert Level 3 in January 2026, and ash fell on 87 villages in May (DZRH, 2026).</a:t>
+              <a:t>•  Many older adults stay home alone while their children work long hours or abroad.</a:t>
             </a:r>
           </a:p>
           <a:p>
@@ -13544,7 +13645,7 @@
                 </a:solidFill>
                 <a:latin typeface="ITC Avant Garde Gothic"/>
               </a:rPr>
-              <a:t>•  Evacuation centers fill up, and ash irritates the eyes and airways (Horwell &amp; Baxter, 2006).</a:t>
+              <a:t>•  A missed medicine, a fever, or a fall can go unnoticed until evening (WHO, 2021).</a:t>
             </a:r>
           </a:p>
           <a:p>
@@ -13560,7 +13661,7 @@
                 </a:solidFill>
                 <a:latin typeface="ITC Avant Garde Gothic"/>
               </a:rPr>
-              <a:t>•  A few health workers must check every evacuee's temperature, pulse, oxygen, and pain.</a:t>
+              <a:t>•  About half of patients on long-term medicines do not take them as prescribed (WHO, 2003).</a:t>
             </a:r>
           </a:p>
           <a:p>
@@ -13576,7 +13677,7 @@
                 </a:solidFill>
                 <a:latin typeface="ITC Avant Garde Gothic"/>
               </a:rPr>
-              <a:t>•  Healthcare robots exist, but they are rigid and cost more than a barangay can pay.</a:t>
+              <a:t>•  Paid caregivers and companion robots cost more than most families can pay.</a:t>
             </a:r>
           </a:p>
         </p:txBody>
@@ -13724,7 +13825,7 @@
                           </a:solidFill>
                           <a:latin typeface="ITC Avant Garde Gothic"/>
                         </a:rPr>
-                        <a:t>Mayon alert level, Jan 2026</a:t>
+                        <a:t>Group with the most fatal falls</a:t>
                       </a:r>
                     </a:p>
                   </a:txBody>
@@ -13746,7 +13847,7 @@
                           </a:solidFill>
                           <a:latin typeface="ITC Avant Garde Gothic"/>
                         </a:rPr>
-                        <a:t>Level 3</a:t>
+                        <a:t>Adults 60+</a:t>
                       </a:r>
                     </a:p>
                   </a:txBody>
@@ -13768,7 +13869,7 @@
                           </a:solidFill>
                           <a:latin typeface="ITC Avant Garde Gothic"/>
                         </a:rPr>
-                        <a:t>DZRH (2026)</a:t>
+                        <a:t>WHO (2021)</a:t>
                       </a:r>
                     </a:p>
                   </a:txBody>
@@ -13792,7 +13893,7 @@
                           </a:solidFill>
                           <a:latin typeface="ITC Avant Garde Gothic"/>
                         </a:rPr>
-                        <a:t>Villages under ash, May 2026</a:t>
+                        <a:t>Adherence to long-term medicines</a:t>
                       </a:r>
                     </a:p>
                   </a:txBody>
@@ -13814,7 +13915,7 @@
                           </a:solidFill>
                           <a:latin typeface="ITC Avant Garde Gothic"/>
                         </a:rPr>
-                        <a:t>87</a:t>
+                        <a:t>About 50%</a:t>
                       </a:r>
                     </a:p>
                   </a:txBody>
@@ -13836,7 +13937,7 @@
                           </a:solidFill>
                           <a:latin typeface="ITC Avant Garde Gothic"/>
                         </a:rPr>
-                        <a:t>Khaosod English (2026)</a:t>
+                        <a:t>WHO (2003)</a:t>
                       </a:r>
                     </a:p>
                   </a:txBody>
@@ -13860,7 +13961,7 @@
                           </a:solidFill>
                           <a:latin typeface="ITC Avant Garde Gothic"/>
                         </a:rPr>
-                        <a:t>Families evacuated, May 2026</a:t>
+                        <a:t>Social robots and older adults' mood</a:t>
                       </a:r>
                     </a:p>
                   </a:txBody>
@@ -13882,7 +13983,7 @@
                           </a:solidFill>
                           <a:latin typeface="ITC Avant Garde Gothic"/>
                         </a:rPr>
-                        <a:t>300+</a:t>
+                        <a:t>Improved</a:t>
                       </a:r>
                     </a:p>
                   </a:txBody>
@@ -13904,7 +14005,7 @@
                           </a:solidFill>
                           <a:latin typeface="ITC Avant Garde Gothic"/>
                         </a:rPr>
-                        <a:t>Khaosod English (2026)</a:t>
+                        <a:t>Pu et al. (2019)</a:t>
                       </a:r>
                     </a:p>
                   </a:txBody>
@@ -13996,7 +14097,7 @@
                           </a:solidFill>
                           <a:latin typeface="ITC Avant Garde Gothic"/>
                         </a:rPr>
-                        <a:t>Pain scale used in screening</a:t>
+                        <a:t>Family care of older adults</a:t>
                       </a:r>
                     </a:p>
                   </a:txBody>
@@ -14018,7 +14119,7 @@
                           </a:solidFill>
                           <a:latin typeface="ITC Avant Garde Gothic"/>
                         </a:rPr>
-                        <a:t>0–10 NRS</a:t>
+                        <a:t>Encouraged by law</a:t>
                       </a:r>
                     </a:p>
                   </a:txBody>
@@ -14040,7 +14141,7 @@
                           </a:solidFill>
                           <a:latin typeface="ITC Avant Garde Gothic"/>
                         </a:rPr>
-                        <a:t>Hawker et al. (2011)</a:t>
+                        <a:t>RA 9994 (2010)</a:t>
                       </a:r>
                     </a:p>
                   </a:txBody>
@@ -14133,7 +14234,7 @@
                 </a:solidFill>
                 <a:latin typeface="ITC Avant Garde Gothic"/>
               </a:rPr>
-              <a:t>Purpose of the study. To find out whether a low-cost soft robot, inspired by the healthcare companion of Big Hero 6, can screen evacuees accurately.</a:t>
+              <a:t>Purpose of the study. To find out whether a low-cost wheeled soft robot, inspired by Big Hero 6, can watch over an older adult at home and keep the family informed.</a:t>
             </a:r>
           </a:p>
         </p:txBody>
@@ -14625,7 +14726,7 @@
                           </a:solidFill>
                           <a:latin typeface="ITC Avant Garde Gothic"/>
                         </a:rPr>
-                        <a:t>Air-filled body that is safe to touch</a:t>
+                        <a:t>Air body that is safe to bump into</a:t>
                       </a:r>
                     </a:p>
                   </a:txBody>
@@ -14649,7 +14750,7 @@
                           </a:solidFill>
                           <a:latin typeface="ITC Avant Garde Gothic"/>
                         </a:rPr>
-                        <a:t>Acceptance of care robots</a:t>
+                        <a:t>Companion robots for older adults</a:t>
                       </a:r>
                     </a:p>
                   </a:txBody>
@@ -14671,7 +14772,7 @@
                           </a:solidFill>
                           <a:latin typeface="ITC Avant Garde Gothic"/>
                         </a:rPr>
-                        <a:t>Broadbent et al. (2009); Mori et al. (2012)</a:t>
+                        <a:t>Wada &amp; Shibata (2007); Pu et al. (2019)</a:t>
                       </a:r>
                     </a:p>
                   </a:txBody>
@@ -14693,7 +14794,7 @@
                           </a:solidFill>
                           <a:latin typeface="ITC Avant Garde Gothic"/>
                         </a:rPr>
-                        <a:t>Friendly look; simple two-dot face</a:t>
+                        <a:t>Company, reminders, friendly face</a:t>
                       </a:r>
                     </a:p>
                   </a:txBody>
@@ -14717,7 +14818,7 @@
                           </a:solidFill>
                           <a:latin typeface="ITC Avant Garde Gothic"/>
                         </a:rPr>
-                        <a:t>Vital-sign sensing</a:t>
+                        <a:t>Falls and medicine adherence</a:t>
                       </a:r>
                     </a:p>
                   </a:txBody>
@@ -14739,7 +14840,7 @@
                           </a:solidFill>
                           <a:latin typeface="ITC Avant Garde Gothic"/>
                         </a:rPr>
-                        <a:t>Jubran (2015); Allen (2007); ISO (2017a, 2017b)</a:t>
+                        <a:t>Bourke et al. (2007); WHO (2003, 2021)</a:t>
                       </a:r>
                     </a:p>
                   </a:txBody>
@@ -14761,7 +14862,7 @@
                           </a:solidFill>
                           <a:latin typeface="ITC Avant Garde Gothic"/>
                         </a:rPr>
-                        <a:t>SpO₂, pulse, and IR temperature limits</a:t>
+                        <a:t>Pendant fall rule; reminders</a:t>
                       </a:r>
                     </a:p>
                   </a:txBody>
@@ -14785,7 +14886,7 @@
                           </a:solidFill>
                           <a:latin typeface="ITC Avant Garde Gothic"/>
                         </a:rPr>
-                        <a:t>Method comparison, usability</a:t>
+                        <a:t>Vital signs, agreement, usability</a:t>
                       </a:r>
                     </a:p>
                   </a:txBody>
@@ -14807,7 +14908,7 @@
                           </a:solidFill>
                           <a:latin typeface="ITC Avant Garde Gothic"/>
                         </a:rPr>
-                        <a:t>Bland &amp; Altman (1986); Brooke (1996)</a:t>
+                        <a:t>Jubran (2015); Bland &amp; Altman (1986); Brooke (1996)</a:t>
                       </a:r>
                     </a:p>
                   </a:txBody>
@@ -14829,7 +14930,7 @@
                           </a:solidFill>
                           <a:latin typeface="ITC Avant Garde Gothic"/>
                         </a:rPr>
-                        <a:t>Agreement statistics and SUS</a:t>
+                        <a:t>Limits, agreement tests, SUS</a:t>
                       </a:r>
                     </a:p>
                   </a:txBody>
@@ -14922,7 +15023,7 @@
                 </a:solidFill>
                 <a:latin typeface="ITC Avant Garde Gothic"/>
               </a:rPr>
-              <a:t>Synthesis. Soft bodies are safer and friendlier, and low-cost sensors can screen vital signs if checked against a reference.</a:t>
+              <a:t>Synthesis. Soft bodies are safer, companion robots help older adults, and falls can be detected with low-cost accelerometers.</a:t>
             </a:r>
           </a:p>
         </p:txBody>
@@ -15370,7 +15471,7 @@
                           </a:solidFill>
                           <a:latin typeface="ITC Avant Garde Gothic"/>
                         </a:rPr>
-                        <a:t>Sanan et al. (2011)</a:t>
+                        <a:t>Wada &amp; Shibata (2007)</a:t>
                       </a:r>
                     </a:p>
                   </a:txBody>
@@ -15392,7 +15493,7 @@
                           </a:solidFill>
                           <a:latin typeface="ITC Avant Garde Gothic"/>
                         </a:rPr>
-                        <a:t>Built an inflatable arm for safe contact with people.</a:t>
+                        <a:t>Placed a seal robot with residents of a care house.</a:t>
                       </a:r>
                     </a:p>
                   </a:txBody>
@@ -15414,7 +15515,7 @@
                           </a:solidFill>
                           <a:latin typeface="ITC Avant Garde Gothic"/>
                         </a:rPr>
-                        <a:t>Supports an air-filled body.</a:t>
+                        <a:t>Supports the companion role.</a:t>
                       </a:r>
                     </a:p>
                   </a:txBody>
@@ -15438,7 +15539,7 @@
                           </a:solidFill>
                           <a:latin typeface="ITC Avant Garde Gothic"/>
                         </a:rPr>
-                        <a:t>Broadbent et al. (2009)</a:t>
+                        <a:t>Bourke et al. (2007)</a:t>
                       </a:r>
                     </a:p>
                   </a:txBody>
@@ -15460,7 +15561,7 @@
                           </a:solidFill>
                           <a:latin typeface="ITC Avant Garde Gothic"/>
                         </a:rPr>
-                        <a:t>Reviewed what makes older adults accept care robots.</a:t>
+                        <a:t>Detected falls with accelerometer thresholds.</a:t>
                       </a:r>
                     </a:p>
                   </a:txBody>
@@ -15482,7 +15583,7 @@
                           </a:solidFill>
                           <a:latin typeface="ITC Avant Garde Gothic"/>
                         </a:rPr>
-                        <a:t>Guides the friendly design.</a:t>
+                        <a:t>Basis of the pendant's fall rule.</a:t>
                       </a:r>
                     </a:p>
                   </a:txBody>
@@ -15643,7 +15744,7 @@
                 </a:solidFill>
                 <a:latin typeface="ITC Avant Garde Gothic"/>
               </a:rPr>
-              <a:t>Synthesis. No low-cost robot joins a soft body, vital-sign screening, and pain triage for evacuation centers.</a:t>
+              <a:t>Synthesis. No low-cost mobile robot joins a soft body, reminders, health checks, fall alerts, and family messages.</a:t>
             </a:r>
           </a:p>
         </p:txBody>
@@ -16106,7 +16207,7 @@
                 </a:solidFill>
                 <a:latin typeface="ITC Avant Garde Gothic"/>
               </a:rPr>
-              <a:t>G1  Few health workers</a:t>
+              <a:t>G1  Alone at home</a:t>
             </a:r>
             <a:r>
               <a:rPr sz="1500" b="0">
@@ -16131,7 +16232,7 @@
                 </a:solidFill>
                 <a:latin typeface="ITC Avant Garde Gothic"/>
               </a:rPr>
-              <a:t>Hundreds of evacuees need routine checks.</a:t>
+              <a:t>Family is away at work all day.</a:t>
             </a:r>
           </a:p>
         </p:txBody>
@@ -16257,7 +16358,7 @@
                 </a:solidFill>
                 <a:latin typeface="ITC Avant Garde Gothic"/>
               </a:rPr>
-              <a:t>Socially assistive robot</a:t>
+              <a:t>Companion + telemonitoring</a:t>
             </a:r>
           </a:p>
           <a:p>
@@ -16273,7 +16374,7 @@
                 </a:solidFill>
                 <a:latin typeface="ITC Avant Garde Gothic"/>
               </a:rPr>
-              <a:t>Robot screens; health workers treat.</a:t>
+              <a:t>Reminders, company, family reports.</a:t>
             </a:r>
           </a:p>
         </p:txBody>
@@ -16358,7 +16459,7 @@
                 </a:solidFill>
                 <a:latin typeface="ITC Avant Garde Gothic"/>
               </a:rPr>
-              <a:t>G2  Robots can scare</a:t>
+              <a:t>G2  Falls unnoticed</a:t>
             </a:r>
             <a:r>
               <a:rPr sz="1500" b="0">
@@ -16383,7 +16484,7 @@
                 </a:solidFill>
                 <a:latin typeface="ITC Avant Garde Gothic"/>
               </a:rPr>
-              <a:t>Rigid or almost-human robots feel unsafe.</a:t>
+              <a:t>The older adult may not reach a phone.</a:t>
             </a:r>
           </a:p>
         </p:txBody>
@@ -16509,7 +16610,7 @@
                 </a:solidFill>
                 <a:latin typeface="ITC Avant Garde Gothic"/>
               </a:rPr>
-              <a:t>Soft body + plain face</a:t>
+              <a:t>Threshold fall detection</a:t>
             </a:r>
           </a:p>
           <a:p>
@@ -16525,7 +16626,7 @@
                 </a:solidFill>
                 <a:latin typeface="ITC Avant Garde Gothic"/>
               </a:rPr>
-              <a:t>Air body; simple face (Mori et al., 2012).</a:t>
+              <a:t>Pendant alerts the family in seconds.</a:t>
             </a:r>
           </a:p>
         </p:txBody>
@@ -16610,7 +16711,7 @@
                 </a:solidFill>
                 <a:latin typeface="ITC Avant Garde Gothic"/>
               </a:rPr>
-              <a:t>G3  Cheap sensors vary</a:t>
+              <a:t>G3  Robots can scare</a:t>
             </a:r>
             <a:r>
               <a:rPr sz="1500" b="0">
@@ -16635,7 +16736,7 @@
                 </a:solidFill>
                 <a:latin typeface="ITC Avant Garde Gothic"/>
               </a:rPr>
-              <a:t>Low-cost modules are rarely validated.</a:t>
+              <a:t>Rigid moving machines in small homes.</a:t>
             </a:r>
           </a:p>
         </p:txBody>
@@ -16761,7 +16862,7 @@
                 </a:solidFill>
                 <a:latin typeface="ITC Avant Garde Gothic"/>
               </a:rPr>
-              <a:t>PPG, IR + agreement</a:t>
+              <a:t>Soft body + plain face</a:t>
             </a:r>
           </a:p>
           <a:p>
@@ -16777,7 +16878,7 @@
                 </a:solidFill>
                 <a:latin typeface="ITC Avant Garde Gothic"/>
               </a:rPr>
-              <a:t>Calibrate, then Bland–Altman test.</a:t>
+              <a:t>Air body, 0.2 m/s, simple face.</a:t>
             </a:r>
           </a:p>
         </p:txBody>
@@ -16862,7 +16963,7 @@
                 </a:solidFill>
                 <a:latin typeface="ITC Avant Garde Gothic"/>
               </a:rPr>
-              <a:t>G4  Who needs help first</a:t>
+              <a:t>G4  Cheap sensors vary</a:t>
             </a:r>
             <a:r>
               <a:rPr sz="1500" b="0">
@@ -16887,7 +16988,7 @@
                 </a:solidFill>
                 <a:latin typeface="ITC Avant Garde Gothic"/>
               </a:rPr>
-              <a:t>Raw numbers mean little to evacuees.</a:t>
+              <a:t>Low-cost modules are rarely validated.</a:t>
             </a:r>
           </a:p>
         </p:txBody>
@@ -17013,7 +17114,7 @@
                 </a:solidFill>
                 <a:latin typeface="ITC Avant Garde Gothic"/>
               </a:rPr>
-              <a:t>State machine + limits</a:t>
+              <a:t>PPG, IR + agreement</a:t>
             </a:r>
           </a:p>
           <a:p>
@@ -17029,7 +17130,7 @@
                 </a:solidFill>
                 <a:latin typeface="ITC Avant Garde Gothic"/>
               </a:rPr>
-              <a:t>GREEN, YELLOW, or RED with spoken advice.</a:t>
+              <a:t>Calibrate, then Bland–Altman test.</a:t>
             </a:r>
           </a:p>
         </p:txBody>
@@ -17506,7 +17607,7 @@
                 </a:solidFill>
                 <a:latin typeface="ITC Avant Garde Gothic"/>
               </a:rPr>
-              <a:t>•  Ripstop nylon body and 12 V blower fan</a:t>
+              <a:t>•  Soft body, fan, wheeled base, motors</a:t>
             </a:r>
           </a:p>
           <a:p>
@@ -17522,7 +17623,7 @@
                 </a:solidFill>
                 <a:latin typeface="ITC Avant Garde Gothic"/>
               </a:rPr>
-              <a:t>•  ESP32, MLX90614, MAX30102, HC-SR04</a:t>
+              <a:t>•  ESP32, line sensor, HC-SR04, bumper</a:t>
             </a:r>
           </a:p>
           <a:p>
@@ -17538,7 +17639,7 @@
                 </a:solidFill>
                 <a:latin typeface="ITC Avant Garde Gothic"/>
               </a:rPr>
-              <a:t>•  OLED, DFPlayer, speaker, pain dial, button</a:t>
+              <a:t>•  MLX90614, MAX30102, OLED, voice, dial</a:t>
             </a:r>
           </a:p>
           <a:p>
@@ -17554,7 +17655,7 @@
                 </a:solidFill>
                 <a:latin typeface="ITC Avant Garde Gothic"/>
               </a:rPr>
-              <a:t>•  Reference thermometer and pulse oximeter</a:t>
+              <a:t>•  Pendant: ESP32-C3 + MPU6050</a:t>
             </a:r>
           </a:p>
           <a:p>
@@ -17570,7 +17671,7 @@
                 </a:solidFill>
                 <a:latin typeface="ITC Avant Garde Gothic"/>
               </a:rPr>
-              <a:t>•  Consenting volunteers (IRB-approved)</a:t>
+              <a:t>•  Wi-Fi, Telegram; reference instruments</a:t>
             </a:r>
           </a:p>
         </p:txBody>
@@ -17708,7 +17809,7 @@
                 </a:solidFill>
                 <a:latin typeface="ITC Avant Garde Gothic"/>
               </a:rPr>
-              <a:t>1.  Sew and seal the inflatable body</a:t>
+              <a:t>1.  Sew the body; build the wheeled base</a:t>
             </a:r>
           </a:p>
           <a:p>
@@ -17724,7 +17825,7 @@
                 </a:solidFill>
                 <a:latin typeface="ITC Avant Garde Gothic"/>
               </a:rPr>
-              <a:t>2.  Wire sensors; program the state machine</a:t>
+              <a:t>2.  Wire and program robot and pendant</a:t>
             </a:r>
           </a:p>
           <a:p>
@@ -17740,7 +17841,7 @@
                 </a:solidFill>
                 <a:latin typeface="ITC Avant Garde Gothic"/>
               </a:rPr>
-              <a:t>3.  Calibrate on 10 volunteers</a:t>
+              <a:t>3.  Tape the mock-home route</a:t>
             </a:r>
           </a:p>
           <a:p>
@@ -17756,7 +17857,7 @@
                 </a:solidFill>
                 <a:latin typeface="ITC Avant Garde Gothic"/>
               </a:rPr>
-              <a:t>4.  Screen volunteers vs reference</a:t>
+              <a:t>4.  Calibrate sensors and fall rule</a:t>
             </a:r>
           </a:p>
           <a:p>
@@ -17772,7 +17873,7 @@
                 </a:solidFill>
                 <a:latin typeface="ITC Avant Garde Gothic"/>
               </a:rPr>
-              <a:t>5.  Logic tests; soft-vs-rigid usability</a:t>
+              <a:t>5.  Navigation, health, fall, reminder tests</a:t>
             </a:r>
           </a:p>
           <a:p>
@@ -17788,7 +17889,7 @@
                 </a:solidFill>
                 <a:latin typeface="ITC Avant Garde Gothic"/>
               </a:rPr>
-              <a:t>6.  Bland–Altman, t-test, Wilcoxon, cost</a:t>
+              <a:t>6.  Usability (soft vs rigid); statistics</a:t>
             </a:r>
           </a:p>
         </p:txBody>
@@ -17926,7 +18027,7 @@
                 </a:solidFill>
                 <a:latin typeface="ITC Avant Garde Gothic"/>
               </a:rPr>
-              <a:t>•  ALAGA prototype</a:t>
+              <a:t>•  ALAGA robot and pendant</a:t>
             </a:r>
           </a:p>
           <a:p>
@@ -17942,7 +18043,7 @@
                 </a:solidFill>
                 <a:latin typeface="ITC Avant Garde Gothic"/>
               </a:rPr>
-              <a:t>•  Bias, limits of agreement, Arms</a:t>
+              <a:t>•  Arrival rate, stop distance</a:t>
             </a:r>
           </a:p>
           <a:p>
@@ -17958,7 +18059,7 @@
                 </a:solidFill>
                 <a:latin typeface="ITC Avant Garde Gothic"/>
               </a:rPr>
-              <a:t>•  Flag sensitivity, specificity</a:t>
+              <a:t>•  Bias, limits of agreement, Arms</a:t>
             </a:r>
           </a:p>
           <a:p>
@@ -17974,7 +18075,7 @@
                 </a:solidFill>
                 <a:latin typeface="ITC Avant Garde Gothic"/>
               </a:rPr>
-              <a:t>•  Screening time (s)</a:t>
+              <a:t>•  Fall sensitivity, specificity, alert time</a:t>
             </a:r>
           </a:p>
           <a:p>
@@ -17990,7 +18091,7 @@
                 </a:solidFill>
                 <a:latin typeface="ITC Avant Garde Gothic"/>
               </a:rPr>
-              <a:t>•  SUS and approachability</a:t>
+              <a:t>•  Reminder punctuality; SUS</a:t>
             </a:r>
           </a:p>
           <a:p>
@@ -18252,7 +18353,7 @@
                 </a:solidFill>
                 <a:latin typeface="ITC Avant Garde Gothic"/>
               </a:rPr>
-              <a:t>Feedback: results tune the calibration offsets and flag limits</a:t>
+              <a:t>Feedback: results tune the calibration, fall thresholds, and speed</a:t>
             </a:r>
           </a:p>
         </p:txBody>
@@ -18622,7 +18723,7 @@
                 </a:solidFill>
                 <a:latin typeface="ITC Avant Garde Gothic"/>
               </a:rPr>
-              <a:t>Evacuees.</a:t>
+              <a:t>Older adults.</a:t>
             </a:r>
             <a:r>
               <a:rPr sz="2000" b="0">
@@ -18631,7 +18732,7 @@
                 </a:solidFill>
                 <a:latin typeface="ITC Avant Garde Gothic"/>
               </a:rPr>
-              <a:t> Children and older adults are screened by a friendly, soft robot without a long wait.</a:t>
+              <a:t> Reminders, health checks, company, and a quick way to call for help when alone.</a:t>
             </a:r>
           </a:p>
           <a:p>
@@ -18647,7 +18748,7 @@
                 </a:solidFill>
                 <a:latin typeface="ITC Avant Garde Gothic"/>
               </a:rPr>
-              <a:t>Health workers.</a:t>
+              <a:t>Working families and OFWs.</a:t>
             </a:r>
             <a:r>
               <a:rPr sz="2000" b="0">
@@ -18656,7 +18757,7 @@
                 </a:solidFill>
                 <a:latin typeface="ITC Avant Garde Gothic"/>
               </a:rPr>
-              <a:t> Routine checks are shared, so more time goes to evacuees flagged YELLOW or RED.</a:t>
+              <a:t> Reports and alerts on their phones; a check-in any time.</a:t>
             </a:r>
           </a:p>
           <a:p>
@@ -18672,7 +18773,7 @@
                 </a:solidFill>
                 <a:latin typeface="ITC Avant Garde Gothic"/>
               </a:rPr>
-              <a:t>LGUs and the PDRRMO.</a:t>
+              <a:t>Barangay health workers and OSCA.</a:t>
             </a:r>
             <a:r>
               <a:rPr sz="2000" b="0">
@@ -18681,7 +18782,7 @@
                 </a:solidFill>
                 <a:latin typeface="ITC Avant Garde Gothic"/>
               </a:rPr>
-              <a:t> An affordable screening aid for every evacuation center.</a:t>
+              <a:t> A low-cost aid for seniors who are alone by day.</a:t>
             </a:r>
           </a:p>
         </p:txBody>
@@ -18720,7 +18821,7 @@
                 </a:solidFill>
                 <a:latin typeface="ITC Avant Garde Gothic"/>
               </a:rPr>
-              <a:t>Schools used as shelters.</a:t>
+              <a:t>Schools and LGUs.</a:t>
             </a:r>
             <a:r>
               <a:rPr sz="2000" b="0">
@@ -18729,7 +18830,7 @@
                 </a:solidFill>
                 <a:latin typeface="ITC Avant Garde Gothic"/>
               </a:rPr>
-              <a:t> The same robot serves the school clinic between disasters.</a:t>
+              <a:t> A local, repairable design that can be built by students.</a:t>
             </a:r>
           </a:p>
           <a:p>
@@ -18828,7 +18929,7 @@
                 </a:solidFill>
                 <a:latin typeface="ITC Avant Garde Gothic"/>
               </a:rPr>
-              <a:t>The study supports SDG 3 (good health), SDG 9 (innovation), and SDG 11.5 (fewer people affected by disasters).</a:t>
+              <a:t>The study supports SDG 3 (good health), SDG 9 (innovation), and SDG 10 (reduced inequalities).</a:t>
             </a:r>
           </a:p>
         </p:txBody>
@@ -19166,7 +19267,7 @@
                 </a:solidFill>
                 <a:latin typeface="ITC Avant Garde Gothic"/>
               </a:rPr>
-              <a:t> This study aimed to design, build, and evaluate ALAGA, a low-cost soft inflatable healthcare companion robot that screens temperature, pulse rate, SpO₂, and pain and flags evacuees who need a health worker.</a:t>
+              <a:t> This study aimed to design, build, and evaluate ALAGA, a low-cost wheeled soft inflatable companion robot that watches over an older adult at home while the family is at work.</a:t>
             </a:r>
           </a:p>
         </p:txBody>
@@ -19336,7 +19437,7 @@
                 </a:solidFill>
                 <a:latin typeface="ITC Avant Garde Gothic"/>
               </a:rPr>
-              <a:t>1.  How closely do ALAGA's temperature, pulse rate, and SpO₂ readings agree with reference instruments (bias, limits of agreement, MAE, Arms)?</a:t>
+              <a:t>1.  How reliably does ALAGA reach each home station (success rate, time, stopping distance)?</a:t>
             </a:r>
           </a:p>
           <a:p>
@@ -19352,7 +19453,7 @@
                 </a:solidFill>
                 <a:latin typeface="ITC Avant Garde Gothic"/>
               </a:rPr>
-              <a:t>2.  How accurately does ALAGA flag readings outside the screening limits (sensitivity, specificity, accuracy)?</a:t>
+              <a:t>2.  How closely do its temperature, pulse rate, and SpO₂ agree with reference instruments?</a:t>
             </a:r>
           </a:p>
           <a:p>
@@ -19368,7 +19469,7 @@
                 </a:solidFill>
                 <a:latin typeface="ITC Avant Garde Gothic"/>
               </a:rPr>
-              <a:t>3.  How long does ALAGA take to complete one screening, from wake-up to spoken result?</a:t>
+              <a:t>3.  How accurately does the pendant detect falls, and how fast do alerts reach the family?</a:t>
             </a:r>
           </a:p>
         </p:txBody>
@@ -19407,7 +19508,7 @@
                 </a:solidFill>
                 <a:latin typeface="ITC Avant Garde Gothic"/>
               </a:rPr>
-              <a:t>4.  How do users rate ALAGA's usability, and is there a significant difference in approachability between the soft body and a rigid shell?</a:t>
+              <a:t>4.  How punctual are reminders, and what share of messages reach the family?</a:t>
             </a:r>
           </a:p>
           <a:p>
@@ -19423,7 +19524,23 @@
                 </a:solidFill>
                 <a:latin typeface="ITC Avant Garde Gothic"/>
               </a:rPr>
-              <a:t>5.  How much does ALAGA cost to build and to run per day?</a:t>
+              <a:t>5.  How do users rate usability, and is the soft body more approachable than a rigid shell?</a:t>
+            </a:r>
+          </a:p>
+          <a:p>
+            <a:pPr algn="l">
+              <a:spcAft>
+                <a:spcPts val="765"/>
+              </a:spcAft>
+            </a:pPr>
+            <a:r>
+              <a:rPr sz="1700" b="0">
+                <a:solidFill>
+                  <a:srgbClr val="2B2020"/>
+                </a:solidFill>
+                <a:latin typeface="ITC Avant Garde Gothic"/>
+              </a:rPr>
+              <a:t>6.  How much does ALAGA cost to build and run?</a:t>
             </a:r>
           </a:p>
         </p:txBody>
@@ -19915,7 +20032,7 @@
                           </a:solidFill>
                           <a:latin typeface="ITC Avant Garde Gothic"/>
                         </a:rPr>
-                        <a:t>Paired t-test; Bland–Altman bias and 95% limits of agreement</a:t>
+                        <a:t>Paired t-test; Bland–Altman limits of agreement</a:t>
                       </a:r>
                     </a:p>
                   </a:txBody>
@@ -19961,7 +20078,75 @@
                           </a:solidFill>
                           <a:latin typeface="ITC Avant Garde Gothic"/>
                         </a:rPr>
-                        <a:t>There is no significant difference in approachability ratings between the soft inflatable body and the rigid shell.</a:t>
+                        <a:t>The pendant's decision is not associated with the true event type (fall or daily activity).</a:t>
+                      </a:r>
+                    </a:p>
+                  </a:txBody>
+                  <a:tcPr>
+                    <a:solidFill>
+                      <a:srgbClr val="F8EAEA"/>
+                    </a:solidFill>
+                  </a:tcPr>
+                </a:tc>
+                <a:tc>
+                  <a:txBody>
+                    <a:bodyPr/>
+                    <a:lstStyle/>
+                    <a:p>
+                      <a:r>
+                        <a:rPr sz="1800" b="0">
+                          <a:solidFill>
+                            <a:srgbClr val="2B2020"/>
+                          </a:solidFill>
+                          <a:latin typeface="ITC Avant Garde Gothic"/>
+                        </a:rPr>
+                        <a:t>Chi-square test of independence</a:t>
+                      </a:r>
+                    </a:p>
+                  </a:txBody>
+                  <a:tcPr>
+                    <a:solidFill>
+                      <a:srgbClr val="F8EAEA"/>
+                    </a:solidFill>
+                  </a:tcPr>
+                </a:tc>
+              </a:tr>
+              <a:tr h="1463040">
+                <a:tc>
+                  <a:txBody>
+                    <a:bodyPr/>
+                    <a:lstStyle/>
+                    <a:p>
+                      <a:r>
+                        <a:rPr sz="1800" b="0">
+                          <a:solidFill>
+                            <a:srgbClr val="8B0707"/>
+                          </a:solidFill>
+                          <a:latin typeface="ITC Avant Garde Gothic"/>
+                        </a:rPr>
+                        <a:t>H₀3</a:t>
+                      </a:r>
+                    </a:p>
+                  </a:txBody>
+                  <a:tcPr>
+                    <a:solidFill>
+                      <a:srgbClr val="F8EAEA"/>
+                    </a:solidFill>
+                  </a:tcPr>
+                </a:tc>
+                <a:tc>
+                  <a:txBody>
+                    <a:bodyPr/>
+                    <a:lstStyle/>
+                    <a:p>
+                      <a:r>
+                        <a:rPr sz="1800" b="0">
+                          <a:solidFill>
+                            <a:srgbClr val="2B2020"/>
+                          </a:solidFill>
+                          <a:latin typeface="ITC Avant Garde Gothic"/>
+                        </a:rPr>
+                        <a:t>There is no significant difference in approachability between the soft body and the rigid shell.</a:t>
                       </a:r>
                     </a:p>
                   </a:txBody>

</xml_diff>